<commit_message>
Presupuesto ajustado a la Convocatoria 56 (seguros, posdoctorado, movilidad 2 %, 11 rubros del Anexo 3), cierre el 3 de noviembre y documentos regenerados
Co-Authored-By: Claude Sonnet 5.5 <noreply@anthropic.com>
Claude-Session: https://claude.ai/code/session_0173LeWkJaFDa3QiKWPAcEXZ
</commit_message>
<xml_diff>
--- a/genesis-e4-e3p00/PROYECTO_COMPLETO/DOCUMENTO/PITCH_DECK_SGR_CONV56_AIRE.pptx
+++ b/genesis-e4-e3p00/PROYECTO_COMPLETO/DOCUMENTO/PITCH_DECK_SGR_CONV56_AIRE.pptx
@@ -4726,7 +4726,7 @@
                 </a:solidFill>
                 <a:latin typeface="DejaVu Sans"/>
               </a:rPr>
-              <a:t>Fecha de corte: 13 de octubre de 2026; fecha límite: 11 de noviembre de 2026</a:t>
+              <a:t>Fecha de corte: 13 de octubre de 2026; fecha límite: 3 de noviembre de 2026</a:t>
             </a:r>
           </a:p>
           <a:p>
@@ -5886,7 +5886,7 @@
                 </a:solidFill>
                 <a:latin typeface="DejaVu Sans"/>
               </a:rPr>
-              <a:t>•  Total: $ 11.377.260.000</a:t>
+              <a:t>•  Total: $ 10.839.840.000</a:t>
             </a:r>
           </a:p>
           <a:p>
@@ -5902,7 +5902,7 @@
                 </a:solidFill>
                 <a:latin typeface="DejaVu Sans"/>
               </a:rPr>
-              <a:t>•  SGR: $ 9.267.260.000 (66,2 % del tope declarado)</a:t>
+              <a:t>•  SGR: $ 8.729.840.000 (62,4 % del tope declarado)</a:t>
             </a:r>
           </a:p>
           <a:p>
@@ -5934,7 +5934,7 @@
                 </a:solidFill>
                 <a:latin typeface="DejaVu Sans"/>
               </a:rPr>
-              <a:t>•  Personal 49,1 %; equipos y software 20,3 %; reserva de contingencia 6,9 %</a:t>
+              <a:t>•  Personal 50,2 %; equipos y software 21,6 %; reserva de contingencia 7,3 %</a:t>
             </a:r>
           </a:p>
           <a:p>
@@ -6498,7 +6498,7 @@
                 </a:solidFill>
                 <a:latin typeface="DejaVu Sans"/>
               </a:rPr>
-              <a:t>•  Solicitud: aprobar y financiar $ 9.267.260.000 con liberación por compuertas</a:t>
+              <a:t>•  Solicitud: aprobar y financiar $ 8.729.840.000 con liberación por compuertas</a:t>
             </a:r>
           </a:p>
           <a:p>

</xml_diff>